<commit_message>
Update documentation and analysis regarding churn predictions and data integrity
- Revised `README.md` to clarify that the dataset cannot determine why customers leave, emphasizing that the observed churn patterns are artifacts of data generation rather than genuine trends.
- Enhanced `ASSUMPTIONS.md` to detail the implications of right-truncation on churn date analysis, reinforcing the need for accurate data interpretation.
- Updated `PRODUCT_QUESTIONS.md` to reflect the findings from notebooks 11-16, highlighting the limitations of the dataset in predicting churn and the withdrawal of previous recommendations based on flawed assumptions.
- Introduced `16_generator_audit.py` to audit the one positive finding, demonstrating that the churn hazard observed is a result of random date generation rather than a true business change.

These changes aim to improve the understanding of the dataset's limitations and ensure accurate communication of findings related to customer churn.
</commit_message>
<xml_diff>
--- a/outputs/AvePoint_Case_Study.pptx
+++ b/outputs/AvePoint_Case_Study.pptx
@@ -516,7 +516,13 @@
           <a:lstStyle/>
           <a:p>
             <a:r>
-              <a:t>Thirty to forty minutes, five parts, following the brief. I say the headline up front because the value of this work is in proving the negative properly and in what we do anyway.</a:t>
+              <a:t>Thirty to forty minutes, five parts, following the brief. I say the headline up front because the value of this work is in proving the negatives properly and in what we do anyway.</a:t>
+            </a:r>
+          </a:p>
+          <a:p/>
+          <a:p>
+            <a:r>
+              <a:t>The second clause is the part to sit on if there is only time for one thing. The strongest result I had — churn accelerating through 2024, p = 2e-16 — is reproduced exactly by a simulation containing nothing but a random number generator. Slide 10 is that test. Finding it is the piece of work I would most want to be judged on.</a:t>
             </a:r>
           </a:p>
         </p:txBody>
@@ -586,7 +592,7 @@
           <a:lstStyle/>
           <a:p>
             <a:r>
-              <a:t>Lead with the target problem. It is the highest-value finding and it shows the instinct to check the label before fitting anything.</a:t>
+              <a:t>Lead with the target problem. Along with slide 10 it is the most valuable thing here, and it shows the instinct to check the label before fitting anything.</a:t>
             </a:r>
           </a:p>
           <a:p/>
@@ -611,6 +617,106 @@
           <a:p>
             <a:r>
               <a:t>Computed in src/audit.py by label_source_agreement and churn_date_coherence, and shown in notebooks 01 and 10.</a:t>
+            </a:r>
+          </a:p>
+        </p:txBody>
+      </p:sp>
+      <p:sp>
+        <p:nvSpPr>
+          <p:cNvPr id="4" name="Slide Number Placeholder 3"/>
+          <p:cNvSpPr>
+            <a:spLocks noGrp="1"/>
+          </p:cNvSpPr>
+          <p:nvPr>
+            <p:ph type="sldNum" idx="5" sz="quarter"/>
+          </p:nvPr>
+        </p:nvSpPr>
+        <p:spPr/>
+      </p:sp>
+    </p:spTree>
+  </p:cSld>
+  <p:clrMapOvr>
+    <a:masterClrMapping/>
+  </p:clrMapOvr>
+</p:notes>
+</file>
+
+<file path=ppt/notesSlides/notesSlide3.xml><?xml version="1.0" encoding="utf-8"?>
+<p:notes xmlns:a="http://schemas.openxmlformats.org/drawingml/2006/main" xmlns:p="http://schemas.openxmlformats.org/presentationml/2006/main" xmlns:r="http://schemas.openxmlformats.org/officeDocument/2006/relationships">
+  <p:cSld>
+    <p:spTree>
+      <p:nvGrpSpPr>
+        <p:cNvPr id="1" name=""/>
+        <p:cNvGrpSpPr/>
+        <p:nvPr/>
+      </p:nvGrpSpPr>
+      <p:grpSpPr>
+        <a:xfrm>
+          <a:off x="0" y="0"/>
+          <a:ext cx="0" cy="0"/>
+          <a:chOff x="0" y="0"/>
+          <a:chExt cx="0" cy="0"/>
+        </a:xfrm>
+      </p:grpSpPr>
+      <p:sp>
+        <p:nvSpPr>
+          <p:cNvPr id="2" name="Slide Image Placeholder 1"/>
+          <p:cNvSpPr>
+            <a:spLocks noGrp="1"/>
+          </p:cNvSpPr>
+          <p:nvPr>
+            <p:ph type="sldImg" idx="2"/>
+          </p:nvPr>
+        </p:nvSpPr>
+        <p:spPr/>
+      </p:sp>
+      <p:sp>
+        <p:nvSpPr>
+          <p:cNvPr id="3" name="Notes Placeholder 2"/>
+          <p:cNvSpPr>
+            <a:spLocks noGrp="1"/>
+          </p:cNvSpPr>
+          <p:nvPr>
+            <p:ph type="body" idx="3" sz="quarter"/>
+          </p:nvPr>
+        </p:nvSpPr>
+        <p:spPr/>
+        <p:txBody>
+          <a:bodyPr/>
+          <a:lstStyle/>
+          <a:p>
+            <a:r>
+              <a:t>This is the slide I would want to be asked about.</a:t>
+            </a:r>
+          </a:p>
+          <a:p/>
+          <a:p>
+            <a:r>
+              <a:t>How the artefact works: no churn date can land after 2024-12-31. If each is drawn uniformly between signup and that boundary, the hazard is 1/(END - t), which rises without limit as t approaches the end. Pooled across accounts that signed up over two years, that is indistinguishable by eye from a business problem.</a:t>
+            </a:r>
+          </a:p>
+          <a:p/>
+          <a:p>
+            <a:r>
+              <a:t>The evidence, in order. Rescale each churn date to its position in the account's own window: uniform, KS p = 0.92 on 600 events, mean position 0.503, and uniform inside every signup quarter. Then the simulation — keep each account's real signup date and real number of churn events, redraw only the dates, run the same survival.calendar_hazard used to produce the original claim, 400 times. Observed rate ratio 1.0893, null 1.0885 with a 95% band of [1.072, 1.106].</a:t>
+            </a:r>
+          </a:p>
+          <a:p/>
+          <a:p>
+            <a:r>
+              <a:t>The p-value is the part worth dwelling on. p = 2e-16 felt like the most secure number I had. The null rule produces a median p of 2.8e-16 — very slightly more significant than the real data. A p-value tells you nothing about whether the null it tests is the one that matters.</a:t>
+            </a:r>
+          </a:p>
+          <a:p/>
+          <a:p>
+            <a:r>
+              <a:t>If asked what I would have done differently: run this before writing the recommendation, not after. On any generated or vendor-supplied extract, simulate the file before trusting a time trend in it.</a:t>
+            </a:r>
+          </a:p>
+          <a:p/>
+          <a:p>
+            <a:r>
+              <a:t>src/generator.py, notebook 16.</a:t>
             </a:r>
           </a:p>
         </p:txBody>
@@ -3677,7 +3783,7 @@
                 </a:solidFill>
                 <a:latin typeface="Calibri"/>
               </a:rPr>
-              <a:t>The short version: the model does not beat a coin flip. The analysis still gives three clear actions.</a:t>
+              <a:t>The short version: no model here beats a coin flip, the one pattern that looked like a cause comes from how the file was written, and three actions still follow.</a:t>
             </a:r>
           </a:p>
         </p:txBody>
@@ -3741,11 +3847,11 @@
             <a:r>
               <a:rPr sz="2800" b="1" i="0">
                 <a:solidFill>
-                  <a:srgbClr val="2E5F8A"/>
-                </a:solidFill>
-                <a:latin typeface="Calibri"/>
-              </a:rPr>
-              <a:t>Find out what changed during 2024</a:t>
+                  <a:srgbClr val="B02E2E"/>
+                </a:solidFill>
+                <a:latin typeface="Calibri"/>
+              </a:rPr>
+              <a:t>Do not go looking for what changed in 2024</a:t>
             </a:r>
           </a:p>
         </p:txBody>
@@ -3796,7 +3902,7 @@
       </p:sp>
       <p:pic>
         <p:nvPicPr>
-          <p:cNvPr id="4" name="Picture 3" descr="12_calendar_hazard.png"/>
+          <p:cNvPr id="4" name="Picture 3" descr="16_generator_artefact.png"/>
           <p:cNvPicPr>
             <a:picLocks noChangeAspect="1"/>
           </p:cNvPicPr>
@@ -3810,8 +3916,8 @@
         </p:blipFill>
         <p:spPr>
           <a:xfrm>
-            <a:off x="2307133" y="1645920"/>
-            <a:ext cx="7577429" cy="3383280"/>
+            <a:off x="1906186" y="1554480"/>
+            <a:ext cx="8379323" cy="2788920"/>
           </a:xfrm>
           <a:prstGeom prst="rect">
             <a:avLst/>
@@ -3826,7 +3932,7 @@
         </p:nvSpPr>
         <p:spPr>
           <a:xfrm>
-            <a:off x="685800" y="5074920"/>
+            <a:off x="685800" y="4572000"/>
             <a:ext cx="10820095" cy="4572000"/>
           </a:xfrm>
           <a:prstGeom prst="rect">
@@ -3852,7 +3958,7 @@
                 </a:solidFill>
                 <a:latin typeface="Calibri"/>
               </a:rPr>
-              <a:t>Each month, more of our customers leave than the month before. In 2023 about 5 in every 100 left each month. By December 2024 it was 22 in every 100. The customer base stayed the same size throughout, so this is not a growth effect. The rise is far too large and too steady to be luck.</a:t>
+              <a:t>Churn looks like it is accelerating. About 5 in every 100 customers left each month in 2023, rising to 22 in 100 by December 2024 — a 2.8x rise per year, p = 2e-16. It was by far the strongest number in this study.</a:t>
             </a:r>
           </a:p>
           <a:p>
@@ -3862,13 +3968,29 @@
               </a:spcAft>
             </a:pPr>
             <a:r>
-              <a:rPr sz="1250" b="0" i="0">
-                <a:solidFill>
-                  <a:srgbClr val="2E5F8A"/>
-                </a:solidFill>
-                <a:latin typeface="Calibri"/>
-              </a:rPr>
-              <a:t>This also explains the model. The cause is hitting every customer at the same time, so comparing customers with each other cannot find it.</a:t>
+              <a:rPr sz="1250" b="1" i="0">
+                <a:solidFill>
+                  <a:srgbClr val="B02E2E"/>
+                </a:solidFill>
+                <a:latin typeface="Calibri"/>
+              </a:rPr>
+              <a:t>It is not a fact about customers. Every churn date in this file is a random date between the day the customer joined and the last day of the extract. A random date has nowhere to go but the end of the file, so the rate climbs on its own, with nothing happening in the business.</a:t>
+            </a:r>
+          </a:p>
+          <a:p>
+            <a:pPr>
+              <a:spcAft>
+                <a:spcPts val="400"/>
+              </a:spcAft>
+            </a:pPr>
+            <a:r>
+              <a:rPr sz="1250" b="1" i="0">
+                <a:solidFill>
+                  <a:srgbClr val="1A1A1A"/>
+                </a:solidFill>
+                <a:latin typeface="Calibri"/>
+              </a:rPr>
+              <a:t>Rebuilding the data from that one rule gives the same answer: a 2.78x rise per year, all 24 months inside the range chance produces, and our result sitting at the 52nd percentile of pure noise. So there is nothing here to investigate, and that is the recommendation.</a:t>
             </a:r>
           </a:p>
         </p:txBody>
@@ -3898,11 +4020,11 @@
             <a:r>
               <a:rPr sz="1150" b="0" i="1">
                 <a:solidFill>
-                  <a:srgbClr val="5A6270"/>
-                </a:solidFill>
-                <a:latin typeface="Calibri"/>
-              </a:rPr>
-              <a:t>What to do: join pricing changes, release dates and competitor events onto this timeline. The data we have holds nothing that changes over time, so this is a clear and answerable request.</a:t>
+                  <a:srgbClr val="1A1A1A"/>
+                </a:solidFill>
+                <a:latin typeface="Calibri"/>
+              </a:rPr>
+              <a:t>The test that mattered was not "is this bigger than noise" — it was, comfortably. It was "would the file produce this on its own". On generated data that is the only null worth testing, and it is the one I had not run.</a:t>
             </a:r>
           </a:p>
         </p:txBody>
@@ -4035,8 +4157,8 @@
         </p:blipFill>
         <p:spPr>
           <a:xfrm>
-            <a:off x="3173168" y="1645920"/>
-            <a:ext cx="5845359" cy="3200400"/>
+            <a:off x="3590694" y="1627632"/>
+            <a:ext cx="5010307" cy="2743200"/>
           </a:xfrm>
           <a:prstGeom prst="rect">
             <a:avLst/>
@@ -4051,7 +4173,7 @@
         </p:nvSpPr>
         <p:spPr>
           <a:xfrm>
-            <a:off x="685800" y="4983480"/>
+            <a:off x="685800" y="4526280"/>
             <a:ext cx="10820095" cy="4572000"/>
           </a:xfrm>
           <a:prstGeom prst="rect">
@@ -4067,33 +4189,83 @@
           <a:p>
             <a:pPr>
               <a:spcAft>
-                <a:spcPts val="900"/>
-              </a:spcAft>
-            </a:pPr>
-            <a:r>
-              <a:rPr sz="1300" b="1" i="0">
+                <a:spcPts val="400"/>
+              </a:spcAft>
+            </a:pPr>
+            <a:r>
+              <a:rPr sz="1250" b="1" i="0">
                 <a:solidFill>
                   <a:srgbClr val="1A1A1A"/>
                 </a:solidFill>
                 <a:latin typeface="Calibri"/>
               </a:rPr>
-              <a:t>At first it looks like new customers are fragile and risk drops with age. That is the standard reason to invest in onboarding, and the evidence for it looks very strong.</a:t>
-            </a:r>
-          </a:p>
-          <a:p>
-            <a:pPr>
-              <a:spcAft>
-                <a:spcPts val="900"/>
-              </a:spcAft>
-            </a:pPr>
-            <a:r>
-              <a:rPr sz="1300" b="1" i="0">
+              <a:t>New customers look fragile, and risk looks like it falls with age. That is the usual reason to fund onboarding, and the evidence for it looks strong: 30-day survival drops from 0.98 for the 2023 intake to 0.59 for the 2024 one, measured at the same age.</a:t>
+            </a:r>
+          </a:p>
+          <a:p>
+            <a:pPr>
+              <a:spcAft>
+                <a:spcPts val="400"/>
+              </a:spcAft>
+            </a:pPr>
+            <a:r>
+              <a:rPr sz="1250" b="1" i="0">
                 <a:solidFill>
                   <a:srgbClr val="B02E2E"/>
                 </a:solidFill>
                 <a:latin typeface="Calibri"/>
               </a:rPr>
-              <a:t>It is not real. Customers who joined recently leave faster at every age. They are also the only ones young enough to appear in the early weeks. Mixing the two makes age look like the cause. Within a single joining month, a customer at day 300 is just as likely to leave as one at day 10.</a:t>
+              <a:t>It is the same random date. A customer who joined recently has a shorter window for that date to land in, so a larger share of their draws fall inside any 90-day question we ask. They look worse at every age without anything about them being worse.</a:t>
+            </a:r>
+          </a:p>
+          <a:p>
+            <a:pPr>
+              <a:spcAft>
+                <a:spcPts val="400"/>
+              </a:spcAft>
+            </a:pPr>
+            <a:r>
+              <a:rPr sz="1250" b="1" i="0">
+                <a:solidFill>
+                  <a:srgbClr val="1A1A1A"/>
+                </a:solidFill>
+                <a:latin typeface="Calibri"/>
+              </a:rPr>
+              <a:t>Simulated data with no tenure effect in it at all clears the significance bar in 93% of runs, and does so more strongly than the real data does (p = 0.002 against 0.006). Within one joining month there is nothing left: a day-300 customer leaves as often as a day-10 one.</a:t>
+            </a:r>
+          </a:p>
+        </p:txBody>
+      </p:sp>
+      <p:sp>
+        <p:nvSpPr>
+          <p:cNvPr id="6" name="TextBox 5"/>
+          <p:cNvSpPr txBox="1"/>
+          <p:nvPr/>
+        </p:nvSpPr>
+        <p:spPr>
+          <a:xfrm>
+            <a:off x="685800" y="6126480"/>
+            <a:ext cx="10820095" cy="502920"/>
+          </a:xfrm>
+          <a:prstGeom prst="rect">
+            <a:avLst/>
+          </a:prstGeom>
+          <a:noFill/>
+        </p:spPr>
+        <p:txBody>
+          <a:bodyPr wrap="square">
+            <a:spAutoFit/>
+          </a:bodyPr>
+          <a:lstStyle/>
+          <a:p>
+            <a:r>
+              <a:rPr sz="1150" b="0" i="1">
+                <a:solidFill>
+                  <a:srgbClr val="5A6270"/>
+                </a:solidFill>
+                <a:latin typeface="Calibri"/>
+              </a:rPr>
+              <a:t>The recommendation does not change; the reason for it gets one layer deeper. This is the same finding as slide 10, applied to a spending decision instead of an investigation.</a:t>
             </a:r>
           </a:p>
         </p:txBody>
@@ -4493,7 +4665,7 @@
                 </a:solidFill>
                 <a:latin typeface="Calibri"/>
               </a:rPr>
-              <a:t>Recommendation 1 is not an A/B test.</a:t>
+              <a:t>Recommendation 1 is not an experiment. It is a data request.</a:t>
             </a:r>
           </a:p>
           <a:p>
@@ -4509,7 +4681,7 @@
                 </a:solidFill>
                 <a:latin typeface="Calibri"/>
               </a:rPr>
-              <a:t>It is a data job. Add the sources that change over time, then rerun this pipeline and compare against the score recorded today.</a:t>
+              <a:t>Nothing in this extract can say why customers leave, because the timestamps were never recorded against the customers they belong to. Ask for an export where they are, then rerun this pipeline and compare against the score written down today.</a:t>
             </a:r>
           </a:p>
           <a:p>
@@ -4822,7 +4994,7 @@
                 </a:solidFill>
                 <a:latin typeface="Calibri"/>
               </a:rPr>
-              <a:t>I would hand them the leakage work, because that is where the judgement that transfers to other projects lives.</a:t>
+              <a:t>I would hand them my own worst mistake on this project, because that is where the judgement that transfers to other work lives.</a:t>
             </a:r>
           </a:p>
           <a:p>
@@ -4850,11 +5022,75 @@
             <a:r>
               <a:rPr sz="1300" b="1" i="0">
                 <a:solidFill>
+                  <a:srgbClr val="B02E2E"/>
+                </a:solidFill>
+                <a:latin typeface="Calibri"/>
+              </a:rPr>
+              <a:t>1. Be hardest on the finding you like.</a:t>
+            </a:r>
+          </a:p>
+          <a:p>
+            <a:pPr lvl="1">
+              <a:spcAft>
+                <a:spcPts val="400"/>
+              </a:spcAft>
+            </a:pPr>
+            <a:r>
+              <a:rPr sz="1100" b="0" i="0">
+                <a:solidFill>
+                  <a:srgbClr val="5A6270"/>
+                </a:solidFill>
+                <a:latin typeface="Calibri"/>
+              </a:rPr>
+              <a:t>I had one positive result and a page of nulls, and I checked the nulls. The positive one was manufactured by the file. Ask of any finding: what else could have produced this, and can I generate it from nothing?</a:t>
+            </a:r>
+          </a:p>
+          <a:p>
+            <a:pPr>
+              <a:spcAft>
+                <a:spcPts val="400"/>
+              </a:spcAft>
+            </a:pPr>
+            <a:r>
+              <a:rPr sz="1300" b="1" i="0">
+                <a:solidFill>
+                  <a:srgbClr val="B02E2E"/>
+                </a:solidFill>
+                <a:latin typeface="Calibri"/>
+              </a:rPr>
+              <a:t>2. A small p-value is not evidence. It is evidence against one null.</a:t>
+            </a:r>
+          </a:p>
+          <a:p>
+            <a:pPr lvl="1">
+              <a:spcAft>
+                <a:spcPts val="400"/>
+              </a:spcAft>
+            </a:pPr>
+            <a:r>
+              <a:rPr sz="1100" b="0" i="0">
+                <a:solidFill>
+                  <a:srgbClr val="5A6270"/>
+                </a:solidFill>
+                <a:latin typeface="Calibri"/>
+              </a:rPr>
+              <a:t>p = 2e-16 felt unarguable. Random dates gave p = 3e-16. If the null is the wrong one, no amount of significance rescues it.</a:t>
+            </a:r>
+          </a:p>
+          <a:p>
+            <a:pPr>
+              <a:spcAft>
+                <a:spcPts val="400"/>
+              </a:spcAft>
+            </a:pPr>
+            <a:r>
+              <a:rPr sz="1300" b="1" i="0">
+                <a:solidFill>
                   <a:srgbClr val="1A1A1A"/>
                 </a:solidFill>
                 <a:latin typeface="Calibri"/>
               </a:rPr>
-              <a:t>1. Start with the target, not the model.</a:t>
+              <a:t>3. Start with the target, not the model.</a:t>
             </a:r>
           </a:p>
           <a:p>
@@ -4870,7 +5106,7 @@
                 </a:solidFill>
                 <a:latin typeface="Calibri"/>
               </a:rPr>
-              <a:t>My first version modelled a flag that turns out to be unrelated to the event log. Counting rows found it. Then check your own check: I first called 38% agreement ‘worse than a coin flip’, and it is not — for two columns this different in size, chance agreement is 39%, not 50%.</a:t>
+              <a:t>My first version modelled a flag unrelated to the event log. Counting rows found it. Then check your own check: I first called 38% agreement ‘worse than a coin flip’, and it is not — for two columns this different in size, chance agreement is 39%, not 50%.</a:t>
             </a:r>
           </a:p>
           <a:p>
@@ -4886,7 +5122,7 @@
                 </a:solidFill>
                 <a:latin typeface="Calibri"/>
               </a:rPr>
-              <a:t>2. Ask of every column: would I really have this on the day I predict?</a:t>
+              <a:t>4. Ask of every column: would I really have this on the day I predict?</a:t>
             </a:r>
           </a:p>
           <a:p>
@@ -4902,7 +5138,7 @@
                 </a:solidFill>
                 <a:latin typeface="Calibri"/>
               </a:rPr>
-              <a:t>Then write that check down so a machine runs it. Careful reading caught the obvious problem. The automatic check caught the one I missed.</a:t>
+              <a:t>Then write the check down so a machine runs it. Reading caught the obvious problem; the automatic check caught the one I missed.</a:t>
             </a:r>
           </a:p>
           <a:p>
@@ -4918,7 +5154,7 @@
                 </a:solidFill>
                 <a:latin typeface="Calibri"/>
               </a:rPr>
-              <a:t>3. A high score is a question, not an answer.</a:t>
+              <a:t>5. Find the floor, and report the range.</a:t>
             </a:r>
           </a:p>
           <a:p>
@@ -4934,7 +5170,7 @@
                 </a:solidFill>
                 <a:latin typeface="Calibri"/>
               </a:rPr>
-              <a:t>The first time they see a great number, it should start a hunt for leakage, not a celebration.</a:t>
+              <a:t>Always run the model with no features first. A range that includes guessing says something the average hides.</a:t>
             </a:r>
           </a:p>
           <a:p>
@@ -4946,11 +5182,11 @@
             <a:r>
               <a:rPr sz="1300" b="1" i="0">
                 <a:solidFill>
-                  <a:srgbClr val="1A1A1A"/>
-                </a:solidFill>
-                <a:latin typeface="Calibri"/>
-              </a:rPr>
-              <a:t>4. Find the floor before you celebrate.</a:t>
+                  <a:srgbClr val="2E5F8A"/>
+                </a:solidFill>
+                <a:latin typeface="Calibri"/>
+              </a:rPr>
+              <a:t>6. Choosing a model is part of fitting it.</a:t>
             </a:r>
           </a:p>
           <a:p>
@@ -4966,71 +5202,7 @@
                 </a:solidFill>
                 <a:latin typeface="Calibri"/>
               </a:rPr>
-              <a:t>Always run the model that uses no features first.</a:t>
-            </a:r>
-          </a:p>
-          <a:p>
-            <a:pPr>
-              <a:spcAft>
-                <a:spcPts val="400"/>
-              </a:spcAft>
-            </a:pPr>
-            <a:r>
-              <a:rPr sz="1300" b="1" i="0">
-                <a:solidFill>
-                  <a:srgbClr val="1A1A1A"/>
-                </a:solidFill>
-                <a:latin typeface="Calibri"/>
-              </a:rPr>
-              <a:t>5. Report the range, not the single number.</a:t>
-            </a:r>
-          </a:p>
-          <a:p>
-            <a:pPr lvl="1">
-              <a:spcAft>
-                <a:spcPts val="400"/>
-              </a:spcAft>
-            </a:pPr>
-            <a:r>
-              <a:rPr sz="1100" b="0" i="0">
-                <a:solidFill>
-                  <a:srgbClr val="5A6270"/>
-                </a:solidFill>
-                <a:latin typeface="Calibri"/>
-              </a:rPr>
-              <a:t>A range that includes guessing tells you something the average hides.</a:t>
-            </a:r>
-          </a:p>
-          <a:p>
-            <a:pPr>
-              <a:spcAft>
-                <a:spcPts val="400"/>
-              </a:spcAft>
-            </a:pPr>
-            <a:r>
-              <a:rPr sz="1300" b="1" i="0">
-                <a:solidFill>
-                  <a:srgbClr val="2E5F8A"/>
-                </a:solidFill>
-                <a:latin typeface="Calibri"/>
-              </a:rPr>
-              <a:t>6. Choosing a model is part of fitting it.</a:t>
-            </a:r>
-          </a:p>
-          <a:p>
-            <a:pPr lvl="1">
-              <a:spcAft>
-                <a:spcPts val="400"/>
-              </a:spcAft>
-            </a:pPr>
-            <a:r>
-              <a:rPr sz="1100" b="0" i="0">
-                <a:solidFill>
-                  <a:srgbClr val="5A6270"/>
-                </a:solidFill>
-                <a:latin typeface="Calibri"/>
-              </a:rPr>
-              <a:t>In this project, the gap between the best model and the honest score was the entire apparent signal. This is the lesson I would spend the most time on.</a:t>
+              <a:t>Here the gap between the best model and the honest score was the entire apparent signal.</a:t>
             </a:r>
           </a:p>
         </p:txBody>
@@ -5064,7 +5236,7 @@
                 </a:solidFill>
                 <a:latin typeface="Calibri"/>
               </a:rPr>
-              <a:t>I would teach it as an experiment, not a lecture. Have them switch off the banned column list and watch AUC jump from 0.58 to 0.79 on its own.</a:t>
+              <a:t>I would teach all of it as experiments rather than lectures. Switch off the banned column list and watch AUC jump from 0.58 to 0.79. Then simulate a dataset with nothing in it and watch it produce a publishable-looking trend.</a:t>
             </a:r>
           </a:p>
         </p:txBody>
@@ -5624,7 +5796,7 @@
                 </a:solidFill>
                 <a:latin typeface="Calibri"/>
               </a:rPr>
-              <a:t>This is what I would build if the model were worth shipping. On these results it is not. Fix the target and the timestamps first, then measure again. The pipeline takes a date, so that is one command.</a:t>
+              <a:t>This is what I would build if the model were worth shipping. On these results it is not, and this extract cannot be repaired into one — the timestamps have to be collected against the right customers, not corrected. Once they are, the pipeline takes a date, so re-measuring is one command.</a:t>
             </a:r>
           </a:p>
         </p:txBody>
@@ -6469,75 +6641,91 @@
           <a:p>
             <a:pPr>
               <a:spcAft>
-                <a:spcPts val="900"/>
-              </a:spcAft>
-            </a:pPr>
-            <a:r>
-              <a:rPr sz="1600" b="1" i="0">
+                <a:spcPts val="500"/>
+              </a:spcAft>
+            </a:pPr>
+            <a:r>
+              <a:rPr sz="1400" b="1" i="0">
                 <a:solidFill>
                   <a:srgbClr val="B02E2E"/>
                 </a:solidFill>
                 <a:latin typeface="Calibri"/>
               </a:rPr>
-              <a:t>The data has real quality problems. I report them rather than quietly patching them.</a:t>
+              <a:t>Two of the five tables are not joined to their customers in time.</a:t>
             </a:r>
           </a:p>
           <a:p>
             <a:pPr lvl="1">
               <a:spcAft>
-                <a:spcPts val="900"/>
-              </a:spcAft>
-            </a:pPr>
-            <a:r>
-              <a:rPr sz="1400" b="0" i="0">
+                <a:spcPts val="500"/>
+              </a:spcAft>
+            </a:pPr>
+            <a:r>
+              <a:rPr sz="1200" b="0" i="0">
                 <a:solidFill>
                   <a:srgbClr val="5A6270"/>
                 </a:solidFill>
                 <a:latin typeface="Calibri"/>
               </a:rPr>
-              <a:t>19,128 of the 24,979 usage records are dated before the subscription they belong to had even started.</a:t>
+              <a:t>Usage and support ticket dates are spread at random across the whole two years. They line up with their own customer's signup date at r = 0.002 and r = 0.014, where 0 means no connection at all.</a:t>
             </a:r>
           </a:p>
           <a:p>
             <a:pPr lvl="1">
               <a:spcAft>
-                <a:spcPts val="900"/>
-              </a:spcAft>
-            </a:pPr>
-            <a:r>
-              <a:rPr sz="1400" b="0" i="0">
+                <a:spcPts val="500"/>
+              </a:spcAft>
+            </a:pPr>
+            <a:r>
+              <a:rPr sz="1200" b="0" i="0">
                 <a:solidFill>
                   <a:srgbClr val="5A6270"/>
                 </a:solidFill>
                 <a:latin typeface="Calibri"/>
               </a:rPr>
-              <a:t>1,077 of the 2,000 support tickets are dated before the customer signed up.</a:t>
+              <a:t>That is what produces the numbers people quote: 19,128 of 24,979 usage rows are dated before the subscription they belong to, and 1,077 of 2,000 tickets before the customer signed up.</a:t>
             </a:r>
           </a:p>
           <a:p>
             <a:pPr lvl="1">
               <a:spcAft>
-                <a:spcPts val="900"/>
-              </a:spcAft>
-            </a:pPr>
-            <a:r>
-              <a:rPr sz="1400" b="0" i="0">
+                <a:spcPts val="500"/>
+              </a:spcAft>
+            </a:pPr>
+            <a:r>
+              <a:rPr sz="1200" b="0" i="0">
                 <a:solidFill>
                   <a:srgbClr val="5A6270"/>
                 </a:solidFill>
                 <a:latin typeface="Calibri"/>
               </a:rPr>
+              <a:t>Nothing links inside those tables either. Ticket priority does not predict how fast we answered. Plan tier does not predict how much people used.</a:t>
+            </a:r>
+          </a:p>
+          <a:p>
+            <a:pPr lvl="1">
+              <a:spcAft>
+                <a:spcPts val="500"/>
+              </a:spcAft>
+            </a:pPr>
+            <a:r>
+              <a:rPr sz="1200" b="0" i="0">
+                <a:solidFill>
+                  <a:srgbClr val="5A6270"/>
+                </a:solidFill>
+                <a:latin typeface="Calibri"/>
+              </a:rPr>
               <a:t>Satisfaction is documented as a 1 to 5 score, but only ever takes the values 3, 4 and 5.</a:t>
             </a:r>
           </a:p>
           <a:p>
             <a:pPr lvl="1">
               <a:spcAft>
-                <a:spcPts val="900"/>
-              </a:spcAft>
-            </a:pPr>
-            <a:r>
-              <a:rPr sz="1400" b="0" i="0">
+                <a:spcPts val="500"/>
+              </a:spcAft>
+            </a:pPr>
+            <a:r>
+              <a:rPr sz="1200" b="0" i="0">
                 <a:solidFill>
                   <a:srgbClr val="5A6270"/>
                 </a:solidFill>
@@ -6549,7 +6737,7 @@
           <a:p>
             <a:pPr>
               <a:spcAft>
-                <a:spcPts val="900"/>
+                <a:spcPts val="500"/>
               </a:spcAft>
             </a:pPr>
             <a:r>
@@ -6565,113 +6753,129 @@
           <a:p>
             <a:pPr>
               <a:spcAft>
-                <a:spcPts val="900"/>
-              </a:spcAft>
-            </a:pPr>
-            <a:r>
-              <a:rPr sz="1600" b="1" i="0">
+                <a:spcPts val="500"/>
+              </a:spcAft>
+            </a:pPr>
+            <a:r>
+              <a:rPr sz="1400" b="1" i="0">
                 <a:solidFill>
                   <a:srgbClr val="1A1A1A"/>
                 </a:solidFill>
                 <a:latin typeface="Calibri"/>
               </a:rPr>
-              <a:t>There is very little to learn from.</a:t>
+              <a:t>Subscriptions is the one table built with rules, and the only one I lean on. Price follows the plan and the seat count, ARR is exactly 12 times MRR, and no subscription starts before its customer did.</a:t>
+            </a:r>
+          </a:p>
+          <a:p>
+            <a:pPr>
+              <a:spcAft>
+                <a:spcPts val="500"/>
+              </a:spcAft>
+            </a:pPr>
+            <a:r>
+              <a:rPr sz="600" b="0" i="0">
+                <a:solidFill>
+                  <a:srgbClr val="1A1A1A"/>
+                </a:solidFill>
+                <a:latin typeface="Calibri"/>
+              </a:rPr>
+              <a:t> </a:t>
+            </a:r>
+          </a:p>
+          <a:p>
+            <a:pPr>
+              <a:spcAft>
+                <a:spcPts val="500"/>
+              </a:spcAft>
+            </a:pPr>
+            <a:r>
+              <a:rPr sz="1400" b="1" i="0">
+                <a:solidFill>
+                  <a:srgbClr val="1A1A1A"/>
+                </a:solidFill>
+                <a:latin typeface="Calibri"/>
+              </a:rPr>
+              <a:t>There is very little to learn from: 54 customers who left, against 73 features. Well under one example per feature, so every result carries a wide range.</a:t>
+            </a:r>
+          </a:p>
+          <a:p>
+            <a:pPr>
+              <a:spcAft>
+                <a:spcPts val="500"/>
+              </a:spcAft>
+            </a:pPr>
+            <a:r>
+              <a:rPr sz="600" b="0" i="0">
+                <a:solidFill>
+                  <a:srgbClr val="1A1A1A"/>
+                </a:solidFill>
+                <a:latin typeface="Calibri"/>
+              </a:rPr>
+              <a:t> </a:t>
+            </a:r>
+          </a:p>
+          <a:p>
+            <a:pPr>
+              <a:spcAft>
+                <a:spcPts val="500"/>
+              </a:spcAft>
+            </a:pPr>
+            <a:r>
+              <a:rPr sz="1400" b="1" i="0">
+                <a:solidFill>
+                  <a:srgbClr val="1A1A1A"/>
+                </a:solidFill>
+                <a:latin typeface="Calibri"/>
+              </a:rPr>
+              <a:t>Assumptions I am making</a:t>
             </a:r>
           </a:p>
           <a:p>
             <a:pPr lvl="1">
               <a:spcAft>
-                <a:spcPts val="900"/>
-              </a:spcAft>
-            </a:pPr>
-            <a:r>
-              <a:rPr sz="1400" b="0" i="0">
+                <a:spcPts val="500"/>
+              </a:spcAft>
+            </a:pPr>
+            <a:r>
+              <a:rPr sz="1200" b="0" i="0">
                 <a:solidFill>
                   <a:srgbClr val="5A6270"/>
                 </a:solidFill>
                 <a:latin typeface="Calibri"/>
               </a:rPr>
-              <a:t>We have 54 customers who left and 73 features. That is well under one example per feature, so every result comes with a wide range.</a:t>
-            </a:r>
-          </a:p>
-          <a:p>
-            <a:pPr>
-              <a:spcAft>
-                <a:spcPts val="900"/>
-              </a:spcAft>
-            </a:pPr>
-            <a:r>
-              <a:rPr sz="600" b="0" i="0">
-                <a:solidFill>
-                  <a:srgbClr val="1A1A1A"/>
-                </a:solidFill>
-                <a:latin typeface="Calibri"/>
-              </a:rPr>
-              <a:t> </a:t>
-            </a:r>
-          </a:p>
-          <a:p>
-            <a:pPr>
-              <a:spcAft>
-                <a:spcPts val="900"/>
-              </a:spcAft>
-            </a:pPr>
-            <a:r>
-              <a:rPr sz="1600" b="1" i="0">
-                <a:solidFill>
-                  <a:srgbClr val="1A1A1A"/>
-                </a:solidFill>
-                <a:latin typeface="Calibri"/>
-              </a:rPr>
-              <a:t>Assumptions I am making</a:t>
+              <a:t>A 90 day window and a 30 June 2024 cutoff. I picked both before testing anything, so they are not chosen to flatter the result.</a:t>
             </a:r>
           </a:p>
           <a:p>
             <a:pPr lvl="1">
               <a:spcAft>
-                <a:spcPts val="900"/>
-              </a:spcAft>
-            </a:pPr>
-            <a:r>
-              <a:rPr sz="1400" b="0" i="0">
+                <a:spcPts val="500"/>
+              </a:spcAft>
+            </a:pPr>
+            <a:r>
+              <a:rPr sz="1200" b="0" i="0">
                 <a:solidFill>
                   <a:srgbClr val="5A6270"/>
                 </a:solidFill>
                 <a:latin typeface="Calibri"/>
               </a:rPr>
-              <a:t>A 90 day window and a 30 June 2024 cutoff. I picked both before testing anything, so they are not chosen to flatter the result.</a:t>
+              <a:t>Customers still active when the data ends are treated as unknown, not as successes.</a:t>
             </a:r>
           </a:p>
           <a:p>
             <a:pPr lvl="1">
               <a:spcAft>
-                <a:spcPts val="900"/>
-              </a:spcAft>
-            </a:pPr>
-            <a:r>
-              <a:rPr sz="1400" b="0" i="0">
+                <a:spcPts val="500"/>
+              </a:spcAft>
+            </a:pPr>
+            <a:r>
+              <a:rPr sz="1200" b="0" i="0">
                 <a:solidFill>
                   <a:srgbClr val="5A6270"/>
                 </a:solidFill>
                 <a:latin typeface="Calibri"/>
               </a:rPr>
-              <a:t>Customers still active when the data ends are treated as unknown, not as successes.</a:t>
-            </a:r>
-          </a:p>
-          <a:p>
-            <a:pPr lvl="1">
-              <a:spcAft>
-                <a:spcPts val="900"/>
-              </a:spcAft>
-            </a:pPr>
-            <a:r>
-              <a:rPr sz="1400" b="0" i="0">
-                <a:solidFill>
-                  <a:srgbClr val="5A6270"/>
-                </a:solidFill>
-                <a:latin typeface="Calibri"/>
-              </a:rPr>
-              <a:t>This is a generated dataset. It may hold no real signal at all, so the work is built to tell that apart from a modelling mistake.</a:t>
+              <a:t>This is a generated dataset, so every finding is tested against a null that imitates the generator — including the findings I liked. Slide 10 is that test, and it is the one that changed the answer.</a:t>
             </a:r>
           </a:p>
         </p:txBody>
@@ -6979,15 +7183,39 @@
           </a:p>
         </p:txBody>
       </p:sp>
-      <p:sp>
-        <p:nvSpPr>
-          <p:cNvPr id="4" name="TextBox 3"/>
+      <p:pic>
+        <p:nvPicPr>
+          <p:cNvPr id="4" name="Picture 3" descr="03_point_in_time.png"/>
+          <p:cNvPicPr>
+            <a:picLocks noChangeAspect="1"/>
+          </p:cNvPicPr>
+          <p:nvPr/>
+        </p:nvPicPr>
+        <p:blipFill>
+          <a:blip r:embed="rId2"/>
+          <a:stretch>
+            <a:fillRect/>
+          </a:stretch>
+        </p:blipFill>
+        <p:spPr>
+          <a:xfrm>
+            <a:off x="1270216" y="1536192"/>
+            <a:ext cx="9651263" cy="2788920"/>
+          </a:xfrm>
+          <a:prstGeom prst="rect">
+            <a:avLst/>
+          </a:prstGeom>
+        </p:spPr>
+      </p:pic>
+      <p:sp>
+        <p:nvSpPr>
+          <p:cNvPr id="5" name="TextBox 4"/>
           <p:cNvSpPr txBox="1"/>
           <p:nvPr/>
         </p:nvSpPr>
         <p:spPr>
           <a:xfrm>
-            <a:off x="685800" y="1719072"/>
+            <a:off x="685800" y="4480560"/>
             <a:ext cx="10820095" cy="4572000"/>
           </a:xfrm>
           <a:prstGeom prst="rect">
@@ -7003,87 +7231,87 @@
           <a:p>
             <a:pPr>
               <a:spcAft>
-                <a:spcPts val="600"/>
-              </a:spcAft>
-            </a:pPr>
-            <a:r>
-              <a:rPr sz="1400" b="1" i="0">
+                <a:spcPts val="300"/>
+              </a:spcAft>
+            </a:pPr>
+            <a:r>
+              <a:rPr sz="1150" b="1" i="0">
                 <a:solidFill>
                   <a:srgbClr val="1A1A1A"/>
                 </a:solidFill>
                 <a:latin typeface="Calibri"/>
               </a:rPr>
-              <a:t>Four families of feature</a:t>
+              <a:t>What each family measures.</a:t>
             </a:r>
           </a:p>
           <a:p>
             <a:pPr lvl="1">
               <a:spcAft>
-                <a:spcPts val="600"/>
-              </a:spcAft>
-            </a:pPr>
-            <a:r>
-              <a:rPr sz="1200" b="0" i="0">
+                <a:spcPts val="300"/>
+              </a:spcAft>
+            </a:pPr>
+            <a:r>
+              <a:rPr sz="950" b="0" i="0">
                 <a:solidFill>
                   <a:srgbClr val="5A6270"/>
                 </a:solidFill>
                 <a:latin typeface="Calibri"/>
               </a:rPr>
-              <a:t>Subscription: how many they have had, what they pay, how steady that payment is, upgrades, downgrades, and how long they have been a customer.</a:t>
+              <a:t>Subscription: what they pay, how steady it is, upgrades, downgrades, how long they have been a customer.  Usage: activity over 30 to 180 days, and whether it is speeding up or slowing down.  Support: ticket load, how fast we answered, how long fixes took, satisfaction, escalations.  Account and ratios: industry, country, how they found us, plan, and per-seat versions of usage and tickets so a 10 seat and a 500 seat customer sit on the same scale.</a:t>
+            </a:r>
+          </a:p>
+          <a:p>
+            <a:pPr>
+              <a:spcAft>
+                <a:spcPts val="300"/>
+              </a:spcAft>
+            </a:pPr>
+            <a:r>
+              <a:rPr sz="600" b="0" i="0">
+                <a:solidFill>
+                  <a:srgbClr val="1A1A1A"/>
+                </a:solidFill>
+                <a:latin typeface="Calibri"/>
+              </a:rPr>
+              <a:t> </a:t>
+            </a:r>
+          </a:p>
+          <a:p>
+            <a:pPr>
+              <a:spcAft>
+                <a:spcPts val="300"/>
+              </a:spcAft>
+            </a:pPr>
+            <a:r>
+              <a:rPr sz="1150" b="1" i="0">
+                <a:solidFill>
+                  <a:srgbClr val="2E5F8A"/>
+                </a:solidFill>
+                <a:latin typeface="Calibri"/>
+              </a:rPr>
+              <a:t>The same code builds these in training and in production.</a:t>
             </a:r>
           </a:p>
           <a:p>
             <a:pPr lvl="1">
               <a:spcAft>
-                <a:spcPts val="600"/>
-              </a:spcAft>
-            </a:pPr>
-            <a:r>
-              <a:rPr sz="1200" b="0" i="0">
+                <a:spcPts val="300"/>
+              </a:spcAft>
+            </a:pPr>
+            <a:r>
+              <a:rPr sz="950" b="0" i="0">
                 <a:solidFill>
                   <a:srgbClr val="5A6270"/>
                 </a:solidFill>
                 <a:latin typeface="Calibri"/>
               </a:rPr>
-              <a:t>Usage: how much they used the product in the last 30, 60, 90 and 180 days. Whether that is speeding up or slowing down. How long the quiet gaps are.</a:t>
-            </a:r>
-          </a:p>
-          <a:p>
-            <a:pPr lvl="1">
-              <a:spcAft>
-                <a:spcPts val="600"/>
-              </a:spcAft>
-            </a:pPr>
-            <a:r>
-              <a:rPr sz="1200" b="0" i="0">
-                <a:solidFill>
-                  <a:srgbClr val="5A6270"/>
-                </a:solidFill>
-                <a:latin typeface="Calibri"/>
-              </a:rPr>
-              <a:t>Support: how many tickets, how fast we answered, how long we took to fix things, their satisfaction scores, and how often things were escalated.</a:t>
-            </a:r>
-          </a:p>
-          <a:p>
-            <a:pPr lvl="1">
-              <a:spcAft>
-                <a:spcPts val="600"/>
-              </a:spcAft>
-            </a:pPr>
-            <a:r>
-              <a:rPr sz="1200" b="0" i="0">
-                <a:solidFill>
-                  <a:srgbClr val="5A6270"/>
-                </a:solidFill>
-                <a:latin typeface="Calibri"/>
-              </a:rPr>
-              <a:t>Ratios: usage and tickets per seat, so a 10 seat customer and a 500 seat customer can be compared fairly.</a:t>
-            </a:r>
-          </a:p>
-          <a:p>
-            <a:pPr>
-              <a:spcAft>
-                <a:spcPts val="600"/>
+              <a:t>Training passes 30 June 2024, production passes today, so the two cannot drift apart. The blanking on the right is the part that reading the code misses: an automatic check found those 5 tickets, I did not.</a:t>
+            </a:r>
+          </a:p>
+          <a:p>
+            <a:pPr>
+              <a:spcAft>
+                <a:spcPts val="300"/>
               </a:spcAft>
             </a:pPr>
             <a:r>
@@ -7099,81 +7327,17 @@
           <a:p>
             <a:pPr>
               <a:spcAft>
-                <a:spcPts val="600"/>
-              </a:spcAft>
-            </a:pPr>
-            <a:r>
-              <a:rPr sz="1400" b="1" i="0">
-                <a:solidFill>
-                  <a:srgbClr val="2E5F8A"/>
-                </a:solidFill>
-                <a:latin typeface="Calibri"/>
-              </a:rPr>
-              <a:t>The important part is that features can only see the past.</a:t>
-            </a:r>
-          </a:p>
-          <a:p>
-            <a:pPr lvl="1">
-              <a:spcAft>
-                <a:spcPts val="600"/>
-              </a:spcAft>
-            </a:pPr>
-            <a:r>
-              <a:rPr sz="1200" b="0" i="0">
-                <a:solidFill>
-                  <a:srgbClr val="5A6270"/>
-                </a:solidFill>
-                <a:latin typeface="Calibri"/>
-              </a:rPr>
-              <a:t>Every calculation takes a date and only looks before it. Training passes 30 June 2024 and production passes today. It is the same code both times, so the two cannot drift apart.</a:t>
-            </a:r>
-          </a:p>
-          <a:p>
-            <a:pPr lvl="1">
-              <a:spcAft>
-                <a:spcPts val="600"/>
-              </a:spcAft>
-            </a:pPr>
-            <a:r>
-              <a:rPr sz="1200" b="0" i="0">
-                <a:solidFill>
-                  <a:srgbClr val="5A6270"/>
-                </a:solidFill>
-                <a:latin typeface="Calibri"/>
-              </a:rPr>
-              <a:t>A ticket opened in June and closed in July still carries a fix time that nobody knew in June. Those fields are blanked. An automatic check caught 5 such tickets that I had missed by reading the code.</a:t>
-            </a:r>
-          </a:p>
-          <a:p>
-            <a:pPr>
-              <a:spcAft>
-                <a:spcPts val="600"/>
-              </a:spcAft>
-            </a:pPr>
-            <a:r>
-              <a:rPr sz="600" b="0" i="0">
-                <a:solidFill>
-                  <a:srgbClr val="1A1A1A"/>
-                </a:solidFill>
-                <a:latin typeface="Calibri"/>
-              </a:rPr>
-              <a:t> </a:t>
-            </a:r>
-          </a:p>
-          <a:p>
-            <a:pPr>
-              <a:spcAft>
-                <a:spcPts val="600"/>
-              </a:spcAft>
-            </a:pPr>
-            <a:r>
-              <a:rPr sz="1400" b="0" i="0">
+                <a:spcPts val="300"/>
+              </a:spcAft>
+            </a:pPr>
+            <a:r>
+              <a:rPr sz="1150" b="0" i="0">
                 <a:solidFill>
                   <a:srgbClr val="B02E2E"/>
                 </a:solidFill>
                 <a:latin typeface="Calibri"/>
               </a:rPr>
-              <a:t>Being honest about what worked: the 21 extra features I engineered made the score slightly worse, not better. I kept them anyway, because swapping to the smaller set just because it scored higher is the exact mistake I warn about later.</a:t>
+              <a:t>Being honest about what worked: the 21 extra features I engineered made the score slightly worse, not better. I kept them anyway, because swapping to the smaller set just because it scored higher is the exact mistake I warn about later. None of them could have helped, for the reason slide 8 gives.</a:t>
             </a:r>
           </a:p>
         </p:txBody>
@@ -7505,11 +7669,11 @@
           <a:p>
             <a:pPr>
               <a:spcAft>
-                <a:spcPts val="500"/>
-              </a:spcAft>
-            </a:pPr>
-            <a:r>
-              <a:rPr sz="1300" b="0" i="0">
+                <a:spcPts val="600"/>
+              </a:spcAft>
+            </a:pPr>
+            <a:r>
+              <a:rPr sz="1350" b="0" i="0">
                 <a:solidFill>
                   <a:srgbClr val="5A6270"/>
                 </a:solidFill>
@@ -7521,11 +7685,11 @@
           <a:p>
             <a:pPr>
               <a:spcAft>
-                <a:spcPts val="500"/>
-              </a:spcAft>
-            </a:pPr>
-            <a:r>
-              <a:rPr sz="1300" b="1" i="0">
+                <a:spcPts val="600"/>
+              </a:spcAft>
+            </a:pPr>
+            <a:r>
+              <a:rPr sz="1350" b="1" i="0">
                 <a:solidFill>
                   <a:srgbClr val="1A1A1A"/>
                 </a:solidFill>
@@ -7537,11 +7701,11 @@
           <a:p>
             <a:pPr>
               <a:spcAft>
-                <a:spcPts val="500"/>
-              </a:spcAft>
-            </a:pPr>
-            <a:r>
-              <a:rPr sz="1300" b="0" i="0">
+                <a:spcPts val="600"/>
+              </a:spcAft>
+            </a:pPr>
+            <a:r>
+              <a:rPr sz="1350" b="0" i="0">
                 <a:solidFill>
                   <a:srgbClr val="5A6270"/>
                 </a:solidFill>
@@ -7553,7 +7717,7 @@
           <a:p>
             <a:pPr>
               <a:spcAft>
-                <a:spcPts val="500"/>
+                <a:spcPts val="600"/>
               </a:spcAft>
             </a:pPr>
             <a:r>
@@ -7569,11 +7733,11 @@
           <a:p>
             <a:pPr>
               <a:spcAft>
-                <a:spcPts val="500"/>
-              </a:spcAft>
-            </a:pPr>
-            <a:r>
-              <a:rPr sz="1300" b="1" i="0">
+                <a:spcPts val="600"/>
+              </a:spcAft>
+            </a:pPr>
+            <a:r>
+              <a:rPr sz="1350" b="1" i="0">
                 <a:solidFill>
                   <a:srgbClr val="B02E2E"/>
                 </a:solidFill>
@@ -7585,11 +7749,11 @@
           <a:p>
             <a:pPr lvl="1">
               <a:spcAft>
-                <a:spcPts val="500"/>
-              </a:spcAft>
-            </a:pPr>
-            <a:r>
-              <a:rPr sz="1100" b="0" i="0">
+                <a:spcPts val="600"/>
+              </a:spcAft>
+            </a:pPr>
+            <a:r>
+              <a:rPr sz="1150" b="0" i="0">
                 <a:solidFill>
                   <a:srgbClr val="5A6270"/>
                 </a:solidFill>
@@ -7601,11 +7765,11 @@
           <a:p>
             <a:pPr lvl="1">
               <a:spcAft>
-                <a:spcPts val="500"/>
-              </a:spcAft>
-            </a:pPr>
-            <a:r>
-              <a:rPr sz="1100" b="0" i="0">
+                <a:spcPts val="600"/>
+              </a:spcAft>
+            </a:pPr>
+            <a:r>
+              <a:rPr sz="1150" b="0" i="0">
                 <a:solidFill>
                   <a:srgbClr val="5A6270"/>
                 </a:solidFill>
@@ -7617,7 +7781,7 @@
           <a:p>
             <a:pPr>
               <a:spcAft>
-                <a:spcPts val="500"/>
+                <a:spcPts val="600"/>
               </a:spcAft>
             </a:pPr>
             <a:r>
@@ -7633,81 +7797,97 @@
           <a:p>
             <a:pPr>
               <a:spcAft>
-                <a:spcPts val="500"/>
-              </a:spcAft>
-            </a:pPr>
-            <a:r>
-              <a:rPr sz="1300" b="1" i="0">
+                <a:spcPts val="600"/>
+              </a:spcAft>
+            </a:pPr>
+            <a:r>
+              <a:rPr sz="1350" b="1" i="0">
                 <a:solidFill>
                   <a:srgbClr val="1A1A1A"/>
                 </a:solidFill>
                 <a:latin typeface="Calibri"/>
               </a:rPr>
-              <a:t>Why the score is low. I tested each possible cause rather than guessing.</a:t>
+              <a:t>Why the score is low. Each cause is measured, not guessed at.</a:t>
             </a:r>
           </a:p>
           <a:p>
             <a:pPr lvl="1">
               <a:spcAft>
-                <a:spcPts val="500"/>
-              </a:spcAft>
-            </a:pPr>
-            <a:r>
-              <a:rPr sz="1100" b="0" i="0">
+                <a:spcPts val="600"/>
+              </a:spcAft>
+            </a:pPr>
+            <a:r>
+              <a:rPr sz="1150" b="0" i="0">
                 <a:solidFill>
                   <a:srgbClr val="5A6270"/>
                 </a:solidFill>
                 <a:latin typeface="Calibri"/>
               </a:rPr>
-              <a:t>Not enough data. This is the main one. Adding rows still improves the score steadily, so we have not hit the ceiling of the method.</a:t>
+              <a:t>The inputs hold nothing. Usage and ticket dates are scattered at random across the two years and match their own customer's signup date at r = 0.002 and r = 0.014. Inside those tables, priority does not predict how fast we answered and plan does not predict how much people used.</a:t>
             </a:r>
           </a:p>
           <a:p>
             <a:pPr lvl="1">
               <a:spcAft>
-                <a:spcPts val="500"/>
-              </a:spcAft>
-            </a:pPr>
-            <a:r>
-              <a:rPr sz="1100" b="0" i="0">
+                <a:spcPts val="600"/>
+              </a:spcAft>
+            </a:pPr>
+            <a:r>
+              <a:rPr sz="1150" b="0" i="0">
                 <a:solidFill>
                   <a:srgbClr val="5A6270"/>
                 </a:solidFill>
                 <a:latin typeface="Calibri"/>
               </a:rPr>
-              <a:t>Target risk, which I cannot put a number on. The target comes from the churn event log, and the other two records of leaving are unrelated to it. At least one of the three is noise and nothing says which.</a:t>
+              <a:t>The target is a random date. Every churn date is a coin toss between the day the customer joined and the last day of the file. Slide 10 is that test.</a:t>
             </a:r>
           </a:p>
           <a:p>
             <a:pPr lvl="1">
               <a:spcAft>
-                <a:spcPts val="500"/>
-              </a:spcAft>
-            </a:pPr>
-            <a:r>
-              <a:rPr sz="1100" b="0" i="0">
+                <a:spcPts val="600"/>
+              </a:spcAft>
+            </a:pPr>
+            <a:r>
+              <a:rPr sz="1150" b="0" i="0">
                 <a:solidFill>
                   <a:srgbClr val="5A6270"/>
                 </a:solidFill>
                 <a:latin typeface="Calibri"/>
               </a:rPr>
-              <a:t>A natural limit in the data. Two customers who look almost identical still end up differently 41% of the time. Two random customers differ 42% of the time. There is almost nothing to separate them on.</a:t>
+              <a:t>Subscriptions is the one table with real rules, and none of it relates to churn.</a:t>
             </a:r>
           </a:p>
           <a:p>
             <a:pPr lvl="1">
               <a:spcAft>
-                <a:spcPts val="500"/>
-              </a:spcAft>
-            </a:pPr>
-            <a:r>
-              <a:rPr sz="1100" b="0" i="0">
+                <a:spcPts val="600"/>
+              </a:spcAft>
+            </a:pPr>
+            <a:r>
+              <a:rPr sz="1150" b="0" i="0">
                 <a:solidFill>
                   <a:srgbClr val="5A6270"/>
                 </a:solidFill>
                 <a:latin typeface="Calibri"/>
               </a:rPr>
-              <a:t>It is not leakage, not the features, and not tuning. I checked all three.</a:t>
+              <a:t>Sample size is real but secondary: 54 churners against 73 features.</a:t>
+            </a:r>
+          </a:p>
+          <a:p>
+            <a:pPr lvl="1">
+              <a:spcAft>
+                <a:spcPts val="600"/>
+              </a:spcAft>
+            </a:pPr>
+            <a:r>
+              <a:rPr sz="1150" b="0" i="0">
+                <a:solidFill>
+                  <a:srgbClr val="5A6270"/>
+                </a:solidFill>
+                <a:latin typeface="Calibri"/>
+              </a:rPr>
+              <a:t>It is not leakage, not the feature build, and not tuning. I checked all three.</a:t>
             </a:r>
           </a:p>
         </p:txBody>
@@ -7741,7 +7921,7 @@
                 </a:solidFill>
                 <a:latin typeface="Calibri"/>
               </a:rPr>
-              <a:t>Scores are ROC-AUC: 0.50 is guessing, 1.00 is perfect. I confirmed the pipeline works by planting targets of known strength — a strong one scores AUC 0.965, a deliberately weak one 0.584, a meaningless one 0.494. The method is fine. The data does not support more.</a:t>
+              <a:t>Scores are ROC-AUC: 0.50 is guessing, 1.00 is perfect. I confirmed the pipeline works by planting targets of known strength — a strong one scores AUC 0.965, a deliberately weak one 0.584, a meaningless one 0.494. The method works. AUC 0.534 is the right answer to the question this data can be asked.</a:t>
             </a:r>
           </a:p>
         </p:txBody>

</xml_diff>